<commit_message>
Kabadiwala deck: cover all 12 official PS requirements (cash, earnings ledger, audio price board, safety guidance, field validation)
Co-Authored-By: Claude Opus 5 <noreply@anthropic.com>
</commit_message>
<xml_diff>
--- a/docs/FireOrbit_SIH26229_KabadiwalaConnect.pptx
+++ b/docs/FireOrbit_SIH26229_KabadiwalaConnect.pptx
@@ -2669,7 +2669,7 @@
                 <a:ea typeface="Times New Roman" pitchFamily="34" charset="-122"/>
                 <a:cs typeface="Times New Roman" pitchFamily="34" charset="-120"/>
               </a:rPr>
-              <a:t>A Hindi / Marathi, voice-first, offline-tolerant Android app: photo → instant fair price → nearest authorized recycler → GPS-stamped digital handover → UPI payment → EPR record.</a:t>
+              <a:t>A Hindi / Marathi, voice-first, offline-capable Android app: photo → instant AI price → audio price board → authorized recycler → GPS-verified handover → cash or UPI, logged in an earnings ledger → EPR record.</a:t>
             </a:r>
             <a:endParaRPr lang="en-US" sz="950" dirty="0"/>
           </a:p>
@@ -3209,7 +3209,7 @@
                 <a:ea typeface="Arial" pitchFamily="34" charset="-122"/>
                 <a:cs typeface="Arial" pitchFamily="34" charset="-120"/>
               </a:rPr>
-              <a:t>🗣️ Hindi / Marathi voice UI · 📴 offline-first · 🪪 collector digital ID · 💳 instant UPI payout · 🛡️ safety training</a:t>
+              <a:t>🗣️ Hindi / Marathi voice UI · 🔊 audio price board · 📴 offline-first · 💵 cash or UPI with OTP receipt · 📒 earnings ledger · 🛡️ safety guidance</a:t>
             </a:r>
             <a:endParaRPr lang="en-US" sz="700" dirty="0"/>
           </a:p>
@@ -3983,7 +3983,7 @@
                 <a:ea typeface="Times New Roman" pitchFamily="34" charset="-122"/>
                 <a:cs typeface="Times New Roman" pitchFamily="34" charset="-120"/>
               </a:rPr>
-              <a:t>GPS + time + weight + QR trace ID, UPI receipt</a:t>
+              <a:t>GPS-verified handover, QR trace ID, cash / UPI receipt</a:t>
             </a:r>
             <a:endParaRPr lang="en-US" sz="700" dirty="0"/>
           </a:p>
@@ -4160,39 +4160,43 @@
           </a:p>
         </p:txBody>
       </p:sp>
-      <p:pic>
-        <p:nvPicPr>
-          <p:cNvPr id="60" name="Image 1" descr="preencoded.png">    </p:cNvPr>
-          <p:cNvPicPr>
-            <a:picLocks noChangeAspect="1"/>
-          </p:cNvPicPr>
-          <p:nvPr/>
-        </p:nvPicPr>
-        <p:blipFill>
-          <a:blip r:embed="rId2"/>
-          <a:srcRect l="0" r="0" t="0" b="0"/>
-          <a:stretch/>
-        </p:blipFill>
-        <p:spPr>
-          <a:xfrm>
-            <a:off x="6400800" y="3794760"/>
-            <a:ext cx="2542032" cy="868680"/>
-          </a:xfrm>
-          <a:prstGeom prst="rect">
-            <a:avLst/>
-          </a:prstGeom>
-        </p:spPr>
-      </p:pic>
-      <p:sp>
-        <p:nvSpPr>
-          <p:cNvPr id="61" name="Text 57"/>
-          <p:cNvSpPr txBox="1"/>
-          <p:nvPr/>
-        </p:nvSpPr>
-        <p:spPr>
-          <a:xfrm>
-            <a:off x="6400800" y="4663440"/>
-            <a:ext cx="2542032" cy="146304"/>
+      <p:sp>
+        <p:nvSpPr>
+          <p:cNvPr id="60" name="Shape 57"/>
+          <p:cNvSpPr/>
+          <p:nvPr/>
+        </p:nvSpPr>
+        <p:spPr>
+          <a:xfrm>
+            <a:off x="6400800" y="3767328"/>
+            <a:ext cx="2542032" cy="1033272"/>
+          </a:xfrm>
+          <a:prstGeom prst="roundRect">
+            <a:avLst>
+              <a:gd name="adj" fmla="val 4425"/>
+            </a:avLst>
+          </a:prstGeom>
+          <a:solidFill>
+            <a:srgbClr val="F0FDF4"/>
+          </a:solidFill>
+          <a:ln w="12700">
+            <a:solidFill>
+              <a:srgbClr val="16A34A"/>
+            </a:solidFill>
+            <a:prstDash val="solid"/>
+          </a:ln>
+        </p:spPr>
+      </p:sp>
+      <p:sp>
+        <p:nvSpPr>
+          <p:cNvPr id="61" name="Text 58"/>
+          <p:cNvSpPr txBox="1"/>
+          <p:nvPr/>
+        </p:nvSpPr>
+        <p:spPr>
+          <a:xfrm>
+            <a:off x="6473952" y="3785616"/>
+            <a:ext cx="2423160" cy="182880"/>
           </a:xfrm>
           <a:prstGeom prst="rect">
             <a:avLst/>
@@ -4204,21 +4208,489 @@
           <a:bodyPr wrap="square" lIns="0" tIns="0" rIns="0" bIns="0" rtlCol="0" anchor="t"/>
           <a:lstStyle/>
           <a:p>
-            <a:pPr algn="r" indent="0" marL="0">
-              <a:buNone/>
-            </a:pPr>
-            <a:r>
-              <a:rPr lang="en-US" sz="650" i="1" dirty="0">
-                <a:solidFill>
-                  <a:srgbClr val="6B7280"/>
-                </a:solidFill>
-                <a:latin typeface="Arial" pitchFamily="34" charset="0"/>
-                <a:ea typeface="Arial" pitchFamily="34" charset="-122"/>
-                <a:cs typeface="Arial" pitchFamily="34" charset="-120"/>
-              </a:rPr>
-              <a:t>recycler &amp; MoM console (mockup)</a:t>
-            </a:r>
-            <a:endParaRPr lang="en-US" sz="650" dirty="0"/>
+            <a:pPr algn="l" indent="0" marL="0">
+              <a:buNone/>
+            </a:pPr>
+            <a:r>
+              <a:rPr lang="en-US" sz="800" b="1" dirty="0">
+                <a:solidFill>
+                  <a:srgbClr val="15803D"/>
+                </a:solidFill>
+                <a:latin typeface="Arial" pitchFamily="34" charset="0"/>
+                <a:ea typeface="Arial" pitchFamily="34" charset="-122"/>
+                <a:cs typeface="Arial" pitchFamily="34" charset="-120"/>
+              </a:rPr>
+              <a:t>✔ Covers all 12 PS requirements</a:t>
+            </a:r>
+            <a:endParaRPr lang="en-US" sz="800" dirty="0"/>
+          </a:p>
+        </p:txBody>
+      </p:sp>
+      <p:sp>
+        <p:nvSpPr>
+          <p:cNvPr id="62" name="Text 59"/>
+          <p:cNvSpPr txBox="1"/>
+          <p:nvPr/>
+        </p:nvSpPr>
+        <p:spPr>
+          <a:xfrm>
+            <a:off x="6473952" y="3986784"/>
+            <a:ext cx="1243584" cy="137160"/>
+          </a:xfrm>
+          <a:prstGeom prst="rect">
+            <a:avLst/>
+          </a:prstGeom>
+          <a:noFill/>
+          <a:ln/>
+        </p:spPr>
+        <p:txBody>
+          <a:bodyPr wrap="square" lIns="0" tIns="0" rIns="0" bIns="0" rtlCol="0" anchor="t"/>
+          <a:lstStyle/>
+          <a:p>
+            <a:pPr algn="l" indent="0" marL="0">
+              <a:buNone/>
+            </a:pPr>
+            <a:r>
+              <a:rPr lang="en-US" sz="580" dirty="0">
+                <a:solidFill>
+                  <a:srgbClr val="1F2937"/>
+                </a:solidFill>
+                <a:latin typeface="Arial" pitchFamily="34" charset="0"/>
+                <a:ea typeface="Arial" pitchFamily="34" charset="-122"/>
+                <a:cs typeface="Arial" pitchFamily="34" charset="-120"/>
+              </a:rPr>
+              <a:t>✔ Photo → AI valuation</a:t>
+            </a:r>
+            <a:endParaRPr lang="en-US" sz="580" dirty="0"/>
+          </a:p>
+        </p:txBody>
+      </p:sp>
+      <p:sp>
+        <p:nvSpPr>
+          <p:cNvPr id="63" name="Text 60"/>
+          <p:cNvSpPr txBox="1"/>
+          <p:nvPr/>
+        </p:nvSpPr>
+        <p:spPr>
+          <a:xfrm>
+            <a:off x="7735824" y="3986784"/>
+            <a:ext cx="1243584" cy="137160"/>
+          </a:xfrm>
+          <a:prstGeom prst="rect">
+            <a:avLst/>
+          </a:prstGeom>
+          <a:noFill/>
+          <a:ln/>
+        </p:spPr>
+        <p:txBody>
+          <a:bodyPr wrap="square" lIns="0" tIns="0" rIns="0" bIns="0" rtlCol="0" anchor="t"/>
+          <a:lstStyle/>
+          <a:p>
+            <a:pPr algn="l" indent="0" marL="0">
+              <a:buNone/>
+            </a:pPr>
+            <a:r>
+              <a:rPr lang="en-US" sz="580" dirty="0">
+                <a:solidFill>
+                  <a:srgbClr val="1F2937"/>
+                </a:solidFill>
+                <a:latin typeface="Arial" pitchFamily="34" charset="0"/>
+                <a:ea typeface="Arial" pitchFamily="34" charset="-122"/>
+                <a:cs typeface="Arial" pitchFamily="34" charset="-120"/>
+              </a:rPr>
+              <a:t>✔ Price history dataset</a:t>
+            </a:r>
+            <a:endParaRPr lang="en-US" sz="580" dirty="0"/>
+          </a:p>
+        </p:txBody>
+      </p:sp>
+      <p:sp>
+        <p:nvSpPr>
+          <p:cNvPr id="64" name="Text 61"/>
+          <p:cNvSpPr txBox="1"/>
+          <p:nvPr/>
+        </p:nvSpPr>
+        <p:spPr>
+          <a:xfrm>
+            <a:off x="6473952" y="4119372"/>
+            <a:ext cx="1243584" cy="137160"/>
+          </a:xfrm>
+          <a:prstGeom prst="rect">
+            <a:avLst/>
+          </a:prstGeom>
+          <a:noFill/>
+          <a:ln/>
+        </p:spPr>
+        <p:txBody>
+          <a:bodyPr wrap="square" lIns="0" tIns="0" rIns="0" bIns="0" rtlCol="0" anchor="t"/>
+          <a:lstStyle/>
+          <a:p>
+            <a:pPr algn="l" indent="0" marL="0">
+              <a:buNone/>
+            </a:pPr>
+            <a:r>
+              <a:rPr lang="en-US" sz="580" dirty="0">
+                <a:solidFill>
+                  <a:srgbClr val="1F2937"/>
+                </a:solidFill>
+                <a:latin typeface="Arial" pitchFamily="34" charset="0"/>
+                <a:ea typeface="Arial" pitchFamily="34" charset="-122"/>
+                <a:cs typeface="Arial" pitchFamily="34" charset="-120"/>
+              </a:rPr>
+              <a:t>✔ End-to-end traceability</a:t>
+            </a:r>
+            <a:endParaRPr lang="en-US" sz="580" dirty="0"/>
+          </a:p>
+        </p:txBody>
+      </p:sp>
+      <p:sp>
+        <p:nvSpPr>
+          <p:cNvPr id="65" name="Text 62"/>
+          <p:cNvSpPr txBox="1"/>
+          <p:nvPr/>
+        </p:nvSpPr>
+        <p:spPr>
+          <a:xfrm>
+            <a:off x="7735824" y="4119372"/>
+            <a:ext cx="1243584" cy="137160"/>
+          </a:xfrm>
+          <a:prstGeom prst="rect">
+            <a:avLst/>
+          </a:prstGeom>
+          <a:noFill/>
+          <a:ln/>
+        </p:spPr>
+        <p:txBody>
+          <a:bodyPr wrap="square" lIns="0" tIns="0" rIns="0" bIns="0" rtlCol="0" anchor="t"/>
+          <a:lstStyle/>
+          <a:p>
+            <a:pPr algn="l" indent="0" marL="0">
+              <a:buNone/>
+            </a:pPr>
+            <a:r>
+              <a:rPr lang="en-US" sz="580" dirty="0">
+                <a:solidFill>
+                  <a:srgbClr val="1F2937"/>
+                </a:solidFill>
+                <a:latin typeface="Arial" pitchFamily="34" charset="0"/>
+                <a:ea typeface="Arial" pitchFamily="34" charset="-122"/>
+                <a:cs typeface="Arial" pitchFamily="34" charset="-120"/>
+              </a:rPr>
+              <a:t>✔ Recycler directory + matching</a:t>
+            </a:r>
+            <a:endParaRPr lang="en-US" sz="580" dirty="0"/>
+          </a:p>
+        </p:txBody>
+      </p:sp>
+      <p:sp>
+        <p:nvSpPr>
+          <p:cNvPr id="66" name="Text 63"/>
+          <p:cNvSpPr txBox="1"/>
+          <p:nvPr/>
+        </p:nvSpPr>
+        <p:spPr>
+          <a:xfrm>
+            <a:off x="6473952" y="4251960"/>
+            <a:ext cx="1243584" cy="137160"/>
+          </a:xfrm>
+          <a:prstGeom prst="rect">
+            <a:avLst/>
+          </a:prstGeom>
+          <a:noFill/>
+          <a:ln/>
+        </p:spPr>
+        <p:txBody>
+          <a:bodyPr wrap="square" lIns="0" tIns="0" rIns="0" bIns="0" rtlCol="0" anchor="t"/>
+          <a:lstStyle/>
+          <a:p>
+            <a:pPr algn="l" indent="0" marL="0">
+              <a:buNone/>
+            </a:pPr>
+            <a:r>
+              <a:rPr lang="en-US" sz="580" dirty="0">
+                <a:solidFill>
+                  <a:srgbClr val="1F2937"/>
+                </a:solidFill>
+                <a:latin typeface="Arial" pitchFamily="34" charset="0"/>
+                <a:ea typeface="Arial" pitchFamily="34" charset="-122"/>
+                <a:cs typeface="Arial" pitchFamily="34" charset="-120"/>
+              </a:rPr>
+              <a:t>✔ Audio price boards</a:t>
+            </a:r>
+            <a:endParaRPr lang="en-US" sz="580" dirty="0"/>
+          </a:p>
+        </p:txBody>
+      </p:sp>
+      <p:sp>
+        <p:nvSpPr>
+          <p:cNvPr id="67" name="Text 64"/>
+          <p:cNvSpPr txBox="1"/>
+          <p:nvPr/>
+        </p:nvSpPr>
+        <p:spPr>
+          <a:xfrm>
+            <a:off x="7735824" y="4251960"/>
+            <a:ext cx="1243584" cy="137160"/>
+          </a:xfrm>
+          <a:prstGeom prst="rect">
+            <a:avLst/>
+          </a:prstGeom>
+          <a:noFill/>
+          <a:ln/>
+        </p:spPr>
+        <p:txBody>
+          <a:bodyPr wrap="square" lIns="0" tIns="0" rIns="0" bIns="0" rtlCol="0" anchor="t"/>
+          <a:lstStyle/>
+          <a:p>
+            <a:pPr algn="l" indent="0" marL="0">
+              <a:buNone/>
+            </a:pPr>
+            <a:r>
+              <a:rPr lang="en-US" sz="580" dirty="0">
+                <a:solidFill>
+                  <a:srgbClr val="1F2937"/>
+                </a:solidFill>
+                <a:latin typeface="Arial" pitchFamily="34" charset="0"/>
+                <a:ea typeface="Arial" pitchFamily="34" charset="-122"/>
+                <a:cs typeface="Arial" pitchFamily="34" charset="-120"/>
+              </a:rPr>
+              <a:t>✔ GPS handover records</a:t>
+            </a:r>
+            <a:endParaRPr lang="en-US" sz="580" dirty="0"/>
+          </a:p>
+        </p:txBody>
+      </p:sp>
+      <p:sp>
+        <p:nvSpPr>
+          <p:cNvPr id="68" name="Text 65"/>
+          <p:cNvSpPr txBox="1"/>
+          <p:nvPr/>
+        </p:nvSpPr>
+        <p:spPr>
+          <a:xfrm>
+            <a:off x="6473952" y="4384548"/>
+            <a:ext cx="1243584" cy="137160"/>
+          </a:xfrm>
+          <a:prstGeom prst="rect">
+            <a:avLst/>
+          </a:prstGeom>
+          <a:noFill/>
+          <a:ln/>
+        </p:spPr>
+        <p:txBody>
+          <a:bodyPr wrap="square" lIns="0" tIns="0" rIns="0" bIns="0" rtlCol="0" anchor="t"/>
+          <a:lstStyle/>
+          <a:p>
+            <a:pPr algn="l" indent="0" marL="0">
+              <a:buNone/>
+            </a:pPr>
+            <a:r>
+              <a:rPr lang="en-US" sz="580" dirty="0">
+                <a:solidFill>
+                  <a:srgbClr val="1F2937"/>
+                </a:solidFill>
+                <a:latin typeface="Arial" pitchFamily="34" charset="0"/>
+                <a:ea typeface="Arial" pitchFamily="34" charset="-122"/>
+                <a:cs typeface="Arial" pitchFamily="34" charset="-120"/>
+              </a:rPr>
+              <a:t>✔ Earnings ledger / history</a:t>
+            </a:r>
+            <a:endParaRPr lang="en-US" sz="580" dirty="0"/>
+          </a:p>
+        </p:txBody>
+      </p:sp>
+      <p:sp>
+        <p:nvSpPr>
+          <p:cNvPr id="69" name="Text 66"/>
+          <p:cNvSpPr txBox="1"/>
+          <p:nvPr/>
+        </p:nvSpPr>
+        <p:spPr>
+          <a:xfrm>
+            <a:off x="7735824" y="4384548"/>
+            <a:ext cx="1243584" cy="137160"/>
+          </a:xfrm>
+          <a:prstGeom prst="rect">
+            <a:avLst/>
+          </a:prstGeom>
+          <a:noFill/>
+          <a:ln/>
+        </p:spPr>
+        <p:txBody>
+          <a:bodyPr wrap="square" lIns="0" tIns="0" rIns="0" bIns="0" rtlCol="0" anchor="t"/>
+          <a:lstStyle/>
+          <a:p>
+            <a:pPr algn="l" indent="0" marL="0">
+              <a:buNone/>
+            </a:pPr>
+            <a:r>
+              <a:rPr lang="en-US" sz="580" dirty="0">
+                <a:solidFill>
+                  <a:srgbClr val="1F2937"/>
+                </a:solidFill>
+                <a:latin typeface="Arial" pitchFamily="34" charset="0"/>
+                <a:ea typeface="Arial" pitchFamily="34" charset="-122"/>
+                <a:cs typeface="Arial" pitchFamily="34" charset="-120"/>
+              </a:rPr>
+              <a:t>✔ Safety guidance built in</a:t>
+            </a:r>
+            <a:endParaRPr lang="en-US" sz="580" dirty="0"/>
+          </a:p>
+        </p:txBody>
+      </p:sp>
+      <p:sp>
+        <p:nvSpPr>
+          <p:cNvPr id="70" name="Text 67"/>
+          <p:cNvSpPr txBox="1"/>
+          <p:nvPr/>
+        </p:nvSpPr>
+        <p:spPr>
+          <a:xfrm>
+            <a:off x="6473952" y="4517136"/>
+            <a:ext cx="1243584" cy="137160"/>
+          </a:xfrm>
+          <a:prstGeom prst="rect">
+            <a:avLst/>
+          </a:prstGeom>
+          <a:noFill/>
+          <a:ln/>
+        </p:spPr>
+        <p:txBody>
+          <a:bodyPr wrap="square" lIns="0" tIns="0" rIns="0" bIns="0" rtlCol="0" anchor="t"/>
+          <a:lstStyle/>
+          <a:p>
+            <a:pPr algn="l" indent="0" marL="0">
+              <a:buNone/>
+            </a:pPr>
+            <a:r>
+              <a:rPr lang="en-US" sz="580" dirty="0">
+                <a:solidFill>
+                  <a:srgbClr val="1F2937"/>
+                </a:solidFill>
+                <a:latin typeface="Arial" pitchFamily="34" charset="0"/>
+                <a:ea typeface="Arial" pitchFamily="34" charset="-122"/>
+                <a:cs typeface="Arial" pitchFamily="34" charset="-120"/>
+              </a:rPr>
+              <a:t>✔ Hindi &amp; Marathi</a:t>
+            </a:r>
+            <a:endParaRPr lang="en-US" sz="580" dirty="0"/>
+          </a:p>
+        </p:txBody>
+      </p:sp>
+      <p:sp>
+        <p:nvSpPr>
+          <p:cNvPr id="71" name="Text 68"/>
+          <p:cNvSpPr txBox="1"/>
+          <p:nvPr/>
+        </p:nvSpPr>
+        <p:spPr>
+          <a:xfrm>
+            <a:off x="7735824" y="4517136"/>
+            <a:ext cx="1243584" cy="137160"/>
+          </a:xfrm>
+          <a:prstGeom prst="rect">
+            <a:avLst/>
+          </a:prstGeom>
+          <a:noFill/>
+          <a:ln/>
+        </p:spPr>
+        <p:txBody>
+          <a:bodyPr wrap="square" lIns="0" tIns="0" rIns="0" bIns="0" rtlCol="0" anchor="t"/>
+          <a:lstStyle/>
+          <a:p>
+            <a:pPr algn="l" indent="0" marL="0">
+              <a:buNone/>
+            </a:pPr>
+            <a:r>
+              <a:rPr lang="en-US" sz="580" dirty="0">
+                <a:solidFill>
+                  <a:srgbClr val="1F2937"/>
+                </a:solidFill>
+                <a:latin typeface="Arial" pitchFamily="34" charset="0"/>
+                <a:ea typeface="Arial" pitchFamily="34" charset="-122"/>
+                <a:cs typeface="Arial" pitchFamily="34" charset="-120"/>
+              </a:rPr>
+              <a:t>✔ Offline-first</a:t>
+            </a:r>
+            <a:endParaRPr lang="en-US" sz="580" dirty="0"/>
+          </a:p>
+        </p:txBody>
+      </p:sp>
+      <p:sp>
+        <p:nvSpPr>
+          <p:cNvPr id="72" name="Text 69"/>
+          <p:cNvSpPr txBox="1"/>
+          <p:nvPr/>
+        </p:nvSpPr>
+        <p:spPr>
+          <a:xfrm>
+            <a:off x="6473952" y="4649724"/>
+            <a:ext cx="1243584" cy="137160"/>
+          </a:xfrm>
+          <a:prstGeom prst="rect">
+            <a:avLst/>
+          </a:prstGeom>
+          <a:noFill/>
+          <a:ln/>
+        </p:spPr>
+        <p:txBody>
+          <a:bodyPr wrap="square" lIns="0" tIns="0" rIns="0" bIns="0" rtlCol="0" anchor="t"/>
+          <a:lstStyle/>
+          <a:p>
+            <a:pPr algn="l" indent="0" marL="0">
+              <a:buNone/>
+            </a:pPr>
+            <a:r>
+              <a:rPr lang="en-US" sz="580" dirty="0">
+                <a:solidFill>
+                  <a:srgbClr val="1F2937"/>
+                </a:solidFill>
+                <a:latin typeface="Arial" pitchFamily="34" charset="0"/>
+                <a:ea typeface="Arial" pitchFamily="34" charset="-122"/>
+                <a:cs typeface="Arial" pitchFamily="34" charset="-120"/>
+              </a:rPr>
+              <a:t>✔ Entry-level Android</a:t>
+            </a:r>
+            <a:endParaRPr lang="en-US" sz="580" dirty="0"/>
+          </a:p>
+        </p:txBody>
+      </p:sp>
+      <p:sp>
+        <p:nvSpPr>
+          <p:cNvPr id="73" name="Text 70"/>
+          <p:cNvSpPr txBox="1"/>
+          <p:nvPr/>
+        </p:nvSpPr>
+        <p:spPr>
+          <a:xfrm>
+            <a:off x="7735824" y="4649724"/>
+            <a:ext cx="1243584" cy="137160"/>
+          </a:xfrm>
+          <a:prstGeom prst="rect">
+            <a:avLst/>
+          </a:prstGeom>
+          <a:noFill/>
+          <a:ln/>
+        </p:spPr>
+        <p:txBody>
+          <a:bodyPr wrap="square" lIns="0" tIns="0" rIns="0" bIns="0" rtlCol="0" anchor="t"/>
+          <a:lstStyle/>
+          <a:p>
+            <a:pPr algn="l" indent="0" marL="0">
+              <a:buNone/>
+            </a:pPr>
+            <a:r>
+              <a:rPr lang="en-US" sz="580" dirty="0">
+                <a:solidFill>
+                  <a:srgbClr val="1F2937"/>
+                </a:solidFill>
+                <a:latin typeface="Arial" pitchFamily="34" charset="0"/>
+                <a:ea typeface="Arial" pitchFamily="34" charset="-122"/>
+                <a:cs typeface="Arial" pitchFamily="34" charset="-120"/>
+              </a:rPr>
+              <a:t>✔ Cash transactions</a:t>
+            </a:r>
+            <a:endParaRPr lang="en-US" sz="580" dirty="0"/>
           </a:p>
         </p:txBody>
       </p:sp>
@@ -5191,7 +5663,7 @@
                 <a:ea typeface="Segoe UI Emoji" pitchFamily="34" charset="-122"/>
                 <a:cs typeface="Segoe UI Emoji" pitchFamily="34" charset="-120"/>
               </a:rPr>
-              <a:t>💳</a:t>
+              <a:t>💵</a:t>
             </a:r>
             <a:endParaRPr lang="en-US" sz="1300" dirty="0"/>
           </a:p>
@@ -5269,7 +5741,7 @@
                 <a:ea typeface="Arial" pitchFamily="34" charset="-122"/>
                 <a:cs typeface="Arial" pitchFamily="34" charset="-120"/>
               </a:rPr>
-              <a:t>UPI instant</a:t>
+              <a:t>cash or UPI + receipt</a:t>
             </a:r>
             <a:endParaRPr lang="en-US" sz="650" dirty="0"/>
           </a:p>
@@ -5333,7 +5805,7 @@
                 <a:ea typeface="Segoe UI Emoji" pitchFamily="34" charset="-122"/>
                 <a:cs typeface="Segoe UI Emoji" pitchFamily="34" charset="-120"/>
               </a:rPr>
-              <a:t>📄</a:t>
+              <a:t>📒</a:t>
             </a:r>
             <a:endParaRPr lang="en-US" sz="1300" dirty="0"/>
           </a:p>
@@ -5372,7 +5844,7 @@
                 <a:ea typeface="Arial" pitchFamily="34" charset="-122"/>
                 <a:cs typeface="Arial" pitchFamily="34" charset="-120"/>
               </a:rPr>
-              <a:t>Record</a:t>
+              <a:t>Ledger</a:t>
             </a:r>
             <a:endParaRPr lang="en-US" sz="850" dirty="0"/>
           </a:p>
@@ -5411,7 +5883,7 @@
                 <a:ea typeface="Arial" pitchFamily="34" charset="-122"/>
                 <a:cs typeface="Arial" pitchFamily="34" charset="-120"/>
               </a:rPr>
-              <a:t>EPR · dataset</a:t>
+              <a:t>earnings · EPR</a:t>
             </a:r>
             <a:endParaRPr lang="en-US" sz="650" dirty="0"/>
           </a:p>
@@ -6325,7 +6797,7 @@
               <a:buNone/>
             </a:pPr>
             <a:r>
-              <a:rPr lang="en-US" sz="650" i="1" dirty="0">
+              <a:rPr lang="en-US" sz="620" i="1" dirty="0">
                 <a:solidFill>
                   <a:srgbClr val="6B7280"/>
                 </a:solidFill>
@@ -6333,9 +6805,9 @@
                 <a:ea typeface="Arial" pitchFamily="34" charset="-122"/>
                 <a:cs typeface="Arial" pitchFamily="34" charset="-120"/>
               </a:rPr>
-              <a:t>Collector app: Snap &amp; Value → authorized recyclers → digital handover receipt (Hindi UI)</a:t>
-            </a:r>
-            <a:endParaRPr lang="en-US" sz="650" dirty="0"/>
+              <a:t>Collector app: Snap &amp; Value + audio price board → authorized recyclers → GPS handover receipt (cash / UPI) with earnings ledger &amp; safety tip</a:t>
+            </a:r>
+            <a:endParaRPr lang="en-US" sz="620" dirty="0"/>
           </a:p>
         </p:txBody>
       </p:sp>
@@ -6685,7 +7157,7 @@
                 <a:ea typeface="Arial" pitchFamily="34" charset="-122"/>
                 <a:cs typeface="Arial" pitchFamily="34" charset="-120"/>
               </a:rPr>
-              <a:t>Vernacular</a:t>
+              <a:t>Vernacular &amp; safety</a:t>
             </a:r>
             <a:endParaRPr lang="en-US" sz="950" dirty="0"/>
           </a:p>
@@ -6724,7 +7196,7 @@
                 <a:ea typeface="Arial" pitchFamily="34" charset="-122"/>
                 <a:cs typeface="Arial" pitchFamily="34" charset="-120"/>
               </a:rPr>
-              <a:t>Bhashini ASR / TTS (Hindi, Marathi), icon-first UI, voice prompts, SMS / IVR fallback</a:t>
+              <a:t>Bhashini ASR / TTS (Hindi, Marathi), audio price boards, icon-first UI, built-in hazardous-handling guidance, SMS / IVR fallback</a:t>
             </a:r>
             <a:endParaRPr lang="en-US" sz="650" dirty="0"/>
           </a:p>
@@ -6998,7 +7470,7 @@
                 <a:ea typeface="Segoe UI Emoji" pitchFamily="34" charset="-122"/>
                 <a:cs typeface="Segoe UI Emoji" pitchFamily="34" charset="-120"/>
               </a:rPr>
-              <a:t>💳</a:t>
+              <a:t>💵</a:t>
             </a:r>
             <a:endParaRPr lang="en-US" sz="1300" dirty="0"/>
           </a:p>
@@ -7037,7 +7509,7 @@
                 <a:ea typeface="Arial" pitchFamily="34" charset="-122"/>
                 <a:cs typeface="Arial" pitchFamily="34" charset="-120"/>
               </a:rPr>
-              <a:t>Payments &amp; ID</a:t>
+              <a:t>Payments &amp; ledger</a:t>
             </a:r>
             <a:endParaRPr lang="en-US" sz="950" dirty="0"/>
           </a:p>
@@ -7076,7 +7548,7 @@
                 <a:ea typeface="Arial" pitchFamily="34" charset="-122"/>
                 <a:cs typeface="Arial" pitchFamily="34" charset="-120"/>
               </a:rPr>
-              <a:t>UPI payouts (NPCI), OTP-confirmed handover, phone-number digital ID, QR receipts</a:t>
+              <a:t>Cash or UPI (NPCI) — both logged with OTP-confirmed receipt; per-collector earnings ledger builds a financial history</a:t>
             </a:r>
             <a:endParaRPr lang="en-US" sz="650" dirty="0"/>
           </a:p>
@@ -7906,7 +8378,7 @@
                 <a:ea typeface="Times New Roman" pitchFamily="34" charset="-122"/>
                 <a:cs typeface="Times New Roman" pitchFamily="34" charset="-120"/>
               </a:rPr>
-              <a:t>pilot with 50 collectors + 3 authorized recyclers in Nagpur (JNARDDC's city), Marathi + Hindi.</a:t>
+              <a:t>PS asks for ≥ 2 real collectors — we plan 50 collectors + 3 authorized recyclers in Nagpur (JNARDDC's city), with a live usability demo.</a:t>
             </a:r>
             <a:endParaRPr lang="en-US" sz="860" dirty="0"/>
           </a:p>
@@ -8245,7 +8717,7 @@
                 <a:ea typeface="Times New Roman" pitchFamily="34" charset="-122"/>
                 <a:cs typeface="Times New Roman" pitchFamily="34" charset="-120"/>
               </a:rPr>
-              <a:t>OTP handover, visible price band, dispute button; only a phone number — no sensitive personal data.</a:t>
+              <a:t>cash stays possible (OTP receipt), visible price band, dispute button; only a phone number — no sensitive personal data.</a:t>
             </a:r>
             <a:endParaRPr lang="en-US" sz="860" dirty="0"/>
           </a:p>
@@ -9746,7 +10218,7 @@
                 <a:ea typeface="Times New Roman" pitchFamily="34" charset="-122"/>
                 <a:cs typeface="Times New Roman" pitchFamily="34" charset="-120"/>
               </a:rPr>
-              <a:t>≈ +25–35 % per kg through fair prices and no middleman cut (pilot target).</a:t>
+              <a:t>≈ +25–35 % per kg via fair prices; earnings ledger builds a financial history for credit.</a:t>
             </a:r>
             <a:endParaRPr lang="en-US" sz="700" dirty="0"/>
           </a:p>
@@ -12863,7 +13335,7 @@
                 <a:ea typeface="Arial" pitchFamily="34" charset="-122"/>
                 <a:cs typeface="Arial" pitchFamily="34" charset="-120"/>
               </a:rPr>
-              <a:t>Field study: 50 collectors + 3 authorized recyclers, Nagpur · unit-economics report (informal vs platform earnings) delivered with the MVP</a:t>
+              <a:t>Deliverables: collector app + recycler module · datasets (materials, prices, recyclers, transactions) · field validation with real collectors (≥ 2 required, 50 planned) · live usability demo · unit-economics report</a:t>
             </a:r>
             <a:endParaRPr lang="en-US" sz="750" dirty="0"/>
           </a:p>

</xml_diff>

<commit_message>
Kabadiwala deck: link to live PWA prototype and repo
Co-Authored-By: Claude Opus 5 <noreply@anthropic.com>
</commit_message>
<xml_diff>
--- a/docs/FireOrbit_SIH26229_KabadiwalaConnect.pptx
+++ b/docs/FireOrbit_SIH26229_KabadiwalaConnect.pptx
@@ -2725,15 +2725,22 @@
               <a:buNone/>
             </a:pPr>
             <a:r>
-              <a:rPr lang="en-US" sz="1000" b="1" dirty="0">
+              <a:rPr lang="en-US" sz="1000" b="1" u="sng" dirty="0">
                 <a:solidFill>
                   <a:srgbClr val="1A0DAB"/>
                 </a:solidFill>
                 <a:latin typeface="Arial" pitchFamily="34" charset="0"/>
                 <a:ea typeface="Arial" pitchFamily="34" charset="-122"/>
                 <a:cs typeface="Arial" pitchFamily="34" charset="-120"/>
-              </a:rPr>
-              <a:t>App mockups</a:t>
+                <a:hlinkClick r:id="rId2" invalidUrl="" action="" tgtFrame="" tooltip="" history="1" highlightClick="0" endSnd="0">
+                  <a:extLst>
+                    <a:ext uri="{A12FA001-AC4F-418D-AE19-62706E023703}">
+                      <ahyp:hlinkClr xmlns:ahyp="http://schemas.microsoft.com/office/drawing/2018/hyperlinkcolor" val="tx"/>
+                    </a:ext>
+                  </a:extLst>
+                </a:hlinkClick>
+              </a:rPr>
+              <a:t>Live App</a:t>
             </a:r>
             <a:endParaRPr lang="en-US" sz="1000" dirty="0"/>
           </a:p>
@@ -2742,15 +2749,22 @@
               <a:buNone/>
             </a:pPr>
             <a:r>
-              <a:rPr lang="en-US" sz="1000" b="1" dirty="0">
+              <a:rPr lang="en-US" sz="1000" b="1" u="sng" dirty="0">
                 <a:solidFill>
                   <a:srgbClr val="1A0DAB"/>
                 </a:solidFill>
                 <a:latin typeface="Arial" pitchFamily="34" charset="0"/>
                 <a:ea typeface="Arial" pitchFamily="34" charset="-122"/>
                 <a:cs typeface="Arial" pitchFamily="34" charset="-120"/>
-              </a:rPr>
-              <a:t>Nagpur pilot plan</a:t>
+                <a:hlinkClick r:id="rId3" invalidUrl="" action="" tgtFrame="" tooltip="" history="1" highlightClick="0" endSnd="0">
+                  <a:extLst>
+                    <a:ext uri="{A12FA001-AC4F-418D-AE19-62706E023703}">
+                      <ahyp:hlinkClr xmlns:ahyp="http://schemas.microsoft.com/office/drawing/2018/hyperlinkcolor" val="tx"/>
+                    </a:ext>
+                  </a:extLst>
+                </a:hlinkClick>
+              </a:rPr>
+              <a:t>GitHub</a:t>
             </a:r>
             <a:endParaRPr lang="en-US" sz="1000" dirty="0"/>
           </a:p>
@@ -2852,7 +2866,7 @@
                 <a:ea typeface="Arial" pitchFamily="34" charset="-122"/>
                 <a:cs typeface="Arial" pitchFamily="34" charset="-120"/>
               </a:rPr>
-              <a:t>screens on the next pages;</a:t>
+              <a:t>installable PWA — open the link</a:t>
             </a:r>
             <a:endParaRPr lang="en-US" sz="750" dirty="0"/>
           </a:p>
@@ -2869,7 +2883,7 @@
                 <a:ea typeface="Arial" pitchFamily="34" charset="-122"/>
                 <a:cs typeface="Arial" pitchFamily="34" charset="-120"/>
               </a:rPr>
-              <a:t>MVP APK in pilot week 4</a:t>
+              <a:t>on any Android phone</a:t>
             </a:r>
             <a:endParaRPr lang="en-US" sz="750" dirty="0"/>
           </a:p>
@@ -5978,15 +5992,22 @@
               <a:buNone/>
             </a:pPr>
             <a:r>
-              <a:rPr lang="en-US" sz="1000" b="1" dirty="0">
+              <a:rPr lang="en-US" sz="1000" b="1" u="sng" dirty="0">
                 <a:solidFill>
                   <a:srgbClr val="1A0DAB"/>
                 </a:solidFill>
                 <a:latin typeface="Arial" pitchFamily="34" charset="0"/>
                 <a:ea typeface="Arial" pitchFamily="34" charset="-122"/>
                 <a:cs typeface="Arial" pitchFamily="34" charset="-120"/>
-              </a:rPr>
-              <a:t>Offline-first</a:t>
+                <a:hlinkClick r:id="rId2" invalidUrl="" action="" tgtFrame="" tooltip="" history="1" highlightClick="0" endSnd="0">
+                  <a:extLst>
+                    <a:ext uri="{A12FA001-AC4F-418D-AE19-62706E023703}">
+                      <ahyp:hlinkClr xmlns:ahyp="http://schemas.microsoft.com/office/drawing/2018/hyperlinkcolor" val="tx"/>
+                    </a:ext>
+                  </a:extLst>
+                </a:hlinkClick>
+              </a:rPr>
+              <a:t>Live App</a:t>
             </a:r>
             <a:endParaRPr lang="en-US" sz="1000" dirty="0"/>
           </a:p>
@@ -5995,15 +6016,22 @@
               <a:buNone/>
             </a:pPr>
             <a:r>
-              <a:rPr lang="en-US" sz="1000" b="1" dirty="0">
+              <a:rPr lang="en-US" sz="1000" b="1" u="sng" dirty="0">
                 <a:solidFill>
                   <a:srgbClr val="1A0DAB"/>
                 </a:solidFill>
                 <a:latin typeface="Arial" pitchFamily="34" charset="0"/>
                 <a:ea typeface="Arial" pitchFamily="34" charset="-122"/>
                 <a:cs typeface="Arial" pitchFamily="34" charset="-120"/>
-              </a:rPr>
-              <a:t>Android 8+</a:t>
+                <a:hlinkClick r:id="rId3" invalidUrl="" action="" tgtFrame="" tooltip="" history="1" highlightClick="0" endSnd="0">
+                  <a:extLst>
+                    <a:ext uri="{A12FA001-AC4F-418D-AE19-62706E023703}">
+                      <ahyp:hlinkClr xmlns:ahyp="http://schemas.microsoft.com/office/drawing/2018/hyperlinkcolor" val="tx"/>
+                    </a:ext>
+                  </a:extLst>
+                </a:hlinkClick>
+              </a:rPr>
+              <a:t>Code</a:t>
             </a:r>
             <a:endParaRPr lang="en-US" sz="1000" dirty="0"/>
           </a:p>
@@ -6757,7 +6785,7 @@
           <p:nvPr/>
         </p:nvPicPr>
         <p:blipFill>
-          <a:blip r:embed="rId2"/>
+          <a:blip r:embed="rId4"/>
           <a:stretch>
             <a:fillRect/>
           </a:stretch>
@@ -8378,7 +8406,7 @@
                 <a:ea typeface="Times New Roman" pitchFamily="34" charset="-122"/>
                 <a:cs typeface="Times New Roman" pitchFamily="34" charset="-120"/>
               </a:rPr>
-              <a:t>PS asks for ≥ 2 real collectors — we plan 50 collectors + 3 authorized recyclers in Nagpur (JNARDDC's city), with a live usability demo.</a:t>
+              <a:t>PS asks for ≥ 2 real collectors — we plan 50 collectors + 3 authorized recyclers in Nagpur (JNARDDC's city); the PWA is live today for the usability demo.</a:t>
             </a:r>
             <a:endParaRPr lang="en-US" sz="860" dirty="0"/>
           </a:p>
@@ -13135,7 +13163,7 @@
                 <a:ea typeface="Arial" pitchFamily="34" charset="-122"/>
                 <a:cs typeface="Arial" pitchFamily="34" charset="-120"/>
               </a:rPr>
-              <a:t>UI / UX — collector app (Hindi) and recycler / MoM console</a:t>
+              <a:t>UI / UX — working collector app (Hindi) and recycler / MoM console</a:t>
             </a:r>
             <a:endParaRPr lang="en-US" sz="900" dirty="0"/>
           </a:p>
@@ -13283,12 +13311,12 @@
         </p:nvSpPr>
         <p:spPr>
           <a:xfrm>
-            <a:off x="274320" y="4599432"/>
-            <a:ext cx="8595360" cy="201168"/>
+            <a:off x="274320" y="4553712"/>
+            <a:ext cx="8595360" cy="256032"/>
           </a:xfrm>
           <a:prstGeom prst="roundRect">
             <a:avLst>
-              <a:gd name="adj" fmla="val 36364"/>
+              <a:gd name="adj" fmla="val 28571"/>
             </a:avLst>
           </a:prstGeom>
           <a:solidFill>
@@ -13310,8 +13338,8 @@
         </p:nvSpPr>
         <p:spPr>
           <a:xfrm>
-            <a:off x="365760" y="4599432"/>
-            <a:ext cx="8412480" cy="201168"/>
+            <a:off x="365760" y="4553712"/>
+            <a:ext cx="8412480" cy="256032"/>
           </a:xfrm>
           <a:prstGeom prst="rect">
             <a:avLst/>
@@ -13327,7 +13355,7 @@
               <a:buNone/>
             </a:pPr>
             <a:r>
-              <a:rPr lang="en-US" sz="750" b="1" dirty="0">
+              <a:rPr lang="en-US" sz="800" b="1" dirty="0">
                 <a:solidFill>
                   <a:srgbClr val="1F3864"/>
                 </a:solidFill>
@@ -13335,9 +13363,65 @@
                 <a:ea typeface="Arial" pitchFamily="34" charset="-122"/>
                 <a:cs typeface="Arial" pitchFamily="34" charset="-120"/>
               </a:rPr>
-              <a:t>Deliverables: collector app + recycler module · datasets (materials, prices, recyclers, transactions) · field validation with real collectors (≥ 2 required, 50 planned) · live usability demo · unit-economics report</a:t>
-            </a:r>
-            <a:endParaRPr lang="en-US" sz="750" dirty="0"/>
+              <a:t>Working prototype (PWA):  </a:t>
+            </a:r>
+            <a:pPr algn="ctr" indent="0" marL="0">
+              <a:buNone/>
+            </a:pPr>
+            <a:r>
+              <a:rPr lang="en-US" sz="800" u="sng" dirty="0">
+                <a:solidFill>
+                  <a:srgbClr val="1A0DAB"/>
+                </a:solidFill>
+                <a:latin typeface="Arial" pitchFamily="34" charset="0"/>
+                <a:ea typeface="Arial" pitchFamily="34" charset="-122"/>
+                <a:cs typeface="Arial" pitchFamily="34" charset="-120"/>
+                <a:hlinkClick r:id="rId13" invalidUrl="" action="" tgtFrame="" tooltip="" history="1" highlightClick="0" endSnd="0">
+                  <a:extLst>
+                    <a:ext uri="{A12FA001-AC4F-418D-AE19-62706E023703}">
+                      <ahyp:hlinkClr xmlns:ahyp="http://schemas.microsoft.com/office/drawing/2018/hyperlinkcolor" val="tx"/>
+                    </a:ext>
+                  </a:extLst>
+                </a:hlinkClick>
+              </a:rPr>
+              <a:t>https://rahulskandagal.github.io/kabadiwala-connect/</a:t>
+            </a:r>
+            <a:pPr algn="ctr" indent="0" marL="0">
+              <a:buNone/>
+            </a:pPr>
+            <a:r>
+              <a:rPr lang="en-US" sz="800" b="1" dirty="0">
+                <a:solidFill>
+                  <a:srgbClr val="1F3864"/>
+                </a:solidFill>
+                <a:latin typeface="Arial" pitchFamily="34" charset="0"/>
+                <a:ea typeface="Arial" pitchFamily="34" charset="-122"/>
+                <a:cs typeface="Arial" pitchFamily="34" charset="-120"/>
+              </a:rPr>
+              <a:t>     Source code:  </a:t>
+            </a:r>
+            <a:pPr algn="ctr" indent="0" marL="0">
+              <a:buNone/>
+            </a:pPr>
+            <a:r>
+              <a:rPr lang="en-US" sz="800" u="sng" dirty="0">
+                <a:solidFill>
+                  <a:srgbClr val="1A0DAB"/>
+                </a:solidFill>
+                <a:latin typeface="Arial" pitchFamily="34" charset="0"/>
+                <a:ea typeface="Arial" pitchFamily="34" charset="-122"/>
+                <a:cs typeface="Arial" pitchFamily="34" charset="-120"/>
+                <a:hlinkClick r:id="rId14" invalidUrl="" action="" tgtFrame="" tooltip="" history="1" highlightClick="0" endSnd="0">
+                  <a:extLst>
+                    <a:ext uri="{A12FA001-AC4F-418D-AE19-62706E023703}">
+                      <ahyp:hlinkClr xmlns:ahyp="http://schemas.microsoft.com/office/drawing/2018/hyperlinkcolor" val="tx"/>
+                    </a:ext>
+                  </a:extLst>
+                </a:hlinkClick>
+              </a:rPr>
+              <a:t>https://github.com/rahulskandagal/kabadiwala-connect</a:t>
+            </a:r>
+            <a:endParaRPr lang="en-US" sz="800" dirty="0"/>
           </a:p>
         </p:txBody>
       </p:sp>

</xml_diff>